<commit_message>
refactor: rename project from Orca to PayLock
- Update module path from github.com/anthropics/orca to github.com/anthropics/paylock
- Rename environment variables: ORCA_* to PAYLOCK_*
- Move cmd/orca to cmd/paylock, contracts/orca to contracts/paylock
- Update all documentation files with new branding
- Update import paths and internal references throughout codebase
</commit_message>
<xml_diff>
--- a/Orca_Presentation.pptx
+++ b/Orca_Presentation.pptx
@@ -3996,8 +3996,12 @@
               <a:t>/</a:t>
             </a:r>
             <a:r>
+              <a:rPr lang="en-US" dirty="0" err="1"/>
+              <a:t>june</a:t>
+            </a:r>
+            <a:r>
               <a:rPr lang="en-US" dirty="0"/>
-              <a:t>June-in-exile</a:t>
+              <a:t>-in-exile</a:t>
             </a:r>
             <a:r>
               <a:rPr dirty="0"/>

</xml_diff>